<commit_message>
presentation update, demo implementation with seperate game instances and LCM, updated demo cube to use automatic aspect ratio to prevent scaling issues, updated device handling to configure new devices that are plugged in
</commit_message>
<xml_diff>
--- a/documents/Henry Frodsham FYP.pptx
+++ b/documents/Henry Frodsham FYP.pptx
@@ -6,13 +6,17 @@
   </p:sldMasterIdLst>
   <p:sldIdLst>
     <p:sldId id="256" r:id="rId2"/>
-    <p:sldId id="257" r:id="rId3"/>
-    <p:sldId id="262" r:id="rId4"/>
-    <p:sldId id="261" r:id="rId5"/>
-    <p:sldId id="263" r:id="rId6"/>
-    <p:sldId id="258" r:id="rId7"/>
-    <p:sldId id="259" r:id="rId8"/>
-    <p:sldId id="260" r:id="rId9"/>
+    <p:sldId id="258" r:id="rId3"/>
+    <p:sldId id="261" r:id="rId4"/>
+    <p:sldId id="257" r:id="rId5"/>
+    <p:sldId id="262" r:id="rId6"/>
+    <p:sldId id="263" r:id="rId7"/>
+    <p:sldId id="265" r:id="rId8"/>
+    <p:sldId id="266" r:id="rId9"/>
+    <p:sldId id="267" r:id="rId10"/>
+    <p:sldId id="268" r:id="rId11"/>
+    <p:sldId id="264" r:id="rId12"/>
+    <p:sldId id="260" r:id="rId13"/>
   </p:sldIdLst>
   <p:sldSz cx="12192000" cy="6858000"/>
   <p:notesSz cx="6858000" cy="9144000"/>
@@ -3377,7 +3381,7 @@
           <a:p>
             <a:r>
               <a:rPr lang="en-US" dirty="0"/>
-              <a:t>Henry Frodsham FYP</a:t>
+              <a:t>Henry Frodsham BSc FYP 2025-26</a:t>
             </a:r>
             <a:endParaRPr lang="en-GB" dirty="0"/>
           </a:p>
@@ -3412,6 +3416,313 @@
     <p:extLst>
       <p:ext uri="{BB962C8B-B14F-4D97-AF65-F5344CB8AC3E}">
         <p14:creationId xmlns:p14="http://schemas.microsoft.com/office/powerpoint/2010/main" val="846470811"/>
+      </p:ext>
+    </p:extLst>
+  </p:cSld>
+  <p:clrMapOvr>
+    <a:masterClrMapping/>
+  </p:clrMapOvr>
+</p:sld>
+</file>
+
+<file path=ppt/slides/slide10.xml><?xml version="1.0" encoding="utf-8"?>
+<p:sld xmlns:a="http://schemas.openxmlformats.org/drawingml/2006/main" xmlns:r="http://schemas.openxmlformats.org/officeDocument/2006/relationships" xmlns:p="http://schemas.openxmlformats.org/presentationml/2006/main">
+  <p:cSld>
+    <p:spTree>
+      <p:nvGrpSpPr>
+        <p:cNvPr id="1" name=""/>
+        <p:cNvGrpSpPr/>
+        <p:nvPr/>
+      </p:nvGrpSpPr>
+      <p:grpSpPr>
+        <a:xfrm>
+          <a:off x="0" y="0"/>
+          <a:ext cx="0" cy="0"/>
+          <a:chOff x="0" y="0"/>
+          <a:chExt cx="0" cy="0"/>
+        </a:xfrm>
+      </p:grpSpPr>
+      <p:sp>
+        <p:nvSpPr>
+          <p:cNvPr id="2" name="Title 1">
+            <a:extLst>
+              <a:ext uri="{FF2B5EF4-FFF2-40B4-BE49-F238E27FC236}">
+                <a16:creationId xmlns:a16="http://schemas.microsoft.com/office/drawing/2014/main" id="{A4D67C12-62BC-8960-7CBE-6D6F21CEBC05}"/>
+              </a:ext>
+            </a:extLst>
+          </p:cNvPr>
+          <p:cNvSpPr>
+            <a:spLocks noGrp="1"/>
+          </p:cNvSpPr>
+          <p:nvPr>
+            <p:ph type="title"/>
+          </p:nvPr>
+        </p:nvSpPr>
+        <p:spPr/>
+        <p:txBody>
+          <a:bodyPr/>
+          <a:lstStyle/>
+          <a:p>
+            <a:r>
+              <a:rPr lang="en-US" dirty="0"/>
+              <a:t>Other </a:t>
+            </a:r>
+            <a:endParaRPr lang="en-GB" dirty="0"/>
+          </a:p>
+        </p:txBody>
+      </p:sp>
+      <p:sp>
+        <p:nvSpPr>
+          <p:cNvPr id="3" name="Content Placeholder 2">
+            <a:extLst>
+              <a:ext uri="{FF2B5EF4-FFF2-40B4-BE49-F238E27FC236}">
+                <a16:creationId xmlns:a16="http://schemas.microsoft.com/office/drawing/2014/main" id="{A8B74D34-6533-6A30-0926-CA6937D31CAF}"/>
+              </a:ext>
+            </a:extLst>
+          </p:cNvPr>
+          <p:cNvSpPr>
+            <a:spLocks noGrp="1"/>
+          </p:cNvSpPr>
+          <p:nvPr>
+            <p:ph idx="1"/>
+          </p:nvPr>
+        </p:nvSpPr>
+        <p:spPr/>
+        <p:txBody>
+          <a:bodyPr/>
+          <a:lstStyle/>
+          <a:p>
+            <a:endParaRPr lang="en-GB"/>
+          </a:p>
+        </p:txBody>
+      </p:sp>
+    </p:spTree>
+    <p:extLst>
+      <p:ext uri="{BB962C8B-B14F-4D97-AF65-F5344CB8AC3E}">
+        <p14:creationId xmlns:p14="http://schemas.microsoft.com/office/powerpoint/2010/main" val="224198796"/>
+      </p:ext>
+    </p:extLst>
+  </p:cSld>
+  <p:clrMapOvr>
+    <a:masterClrMapping/>
+  </p:clrMapOvr>
+</p:sld>
+</file>
+
+<file path=ppt/slides/slide11.xml><?xml version="1.0" encoding="utf-8"?>
+<p:sld xmlns:a="http://schemas.openxmlformats.org/drawingml/2006/main" xmlns:r="http://schemas.openxmlformats.org/officeDocument/2006/relationships" xmlns:p="http://schemas.openxmlformats.org/presentationml/2006/main">
+  <p:cSld>
+    <p:spTree>
+      <p:nvGrpSpPr>
+        <p:cNvPr id="1" name=""/>
+        <p:cNvGrpSpPr/>
+        <p:nvPr/>
+      </p:nvGrpSpPr>
+      <p:grpSpPr>
+        <a:xfrm>
+          <a:off x="0" y="0"/>
+          <a:ext cx="0" cy="0"/>
+          <a:chOff x="0" y="0"/>
+          <a:chExt cx="0" cy="0"/>
+        </a:xfrm>
+      </p:grpSpPr>
+      <p:sp>
+        <p:nvSpPr>
+          <p:cNvPr id="2" name="Title 1">
+            <a:extLst>
+              <a:ext uri="{FF2B5EF4-FFF2-40B4-BE49-F238E27FC236}">
+                <a16:creationId xmlns:a16="http://schemas.microsoft.com/office/drawing/2014/main" id="{C47BF52C-3872-4408-1366-972E1C245FE4}"/>
+              </a:ext>
+            </a:extLst>
+          </p:cNvPr>
+          <p:cNvSpPr>
+            <a:spLocks noGrp="1"/>
+          </p:cNvSpPr>
+          <p:nvPr>
+            <p:ph type="title"/>
+          </p:nvPr>
+        </p:nvSpPr>
+        <p:spPr/>
+        <p:txBody>
+          <a:bodyPr/>
+          <a:lstStyle/>
+          <a:p>
+            <a:r>
+              <a:rPr lang="en-US" dirty="0"/>
+              <a:t>Major design patterns </a:t>
+            </a:r>
+            <a:r>
+              <a:rPr lang="en-US" dirty="0" err="1"/>
+              <a:t>ive</a:t>
+            </a:r>
+            <a:r>
+              <a:rPr lang="en-US" dirty="0"/>
+              <a:t> used – Event architecture</a:t>
+            </a:r>
+            <a:endParaRPr lang="en-GB" dirty="0"/>
+          </a:p>
+        </p:txBody>
+      </p:sp>
+      <p:sp>
+        <p:nvSpPr>
+          <p:cNvPr id="3" name="Content Placeholder 2">
+            <a:extLst>
+              <a:ext uri="{FF2B5EF4-FFF2-40B4-BE49-F238E27FC236}">
+                <a16:creationId xmlns:a16="http://schemas.microsoft.com/office/drawing/2014/main" id="{04469C97-239F-A2C4-55E5-0902A5AB5B6F}"/>
+              </a:ext>
+            </a:extLst>
+          </p:cNvPr>
+          <p:cNvSpPr>
+            <a:spLocks noGrp="1"/>
+          </p:cNvSpPr>
+          <p:nvPr>
+            <p:ph idx="1"/>
+          </p:nvPr>
+        </p:nvSpPr>
+        <p:spPr>
+          <a:xfrm>
+            <a:off x="838200" y="1825625"/>
+            <a:ext cx="4738991" cy="4351338"/>
+          </a:xfrm>
+        </p:spPr>
+        <p:txBody>
+          <a:bodyPr/>
+          <a:lstStyle/>
+          <a:p>
+            <a:pPr marL="0" indent="0">
+              <a:buNone/>
+            </a:pPr>
+            <a:r>
+              <a:rPr lang="en-US" b="1" dirty="0"/>
+              <a:t>What is event architecture?</a:t>
+            </a:r>
+            <a:br>
+              <a:rPr lang="en-US" b="1" dirty="0"/>
+            </a:br>
+            <a:br>
+              <a:rPr lang="en-US" b="1" dirty="0"/>
+            </a:br>
+            <a:r>
+              <a:rPr lang="en-US" dirty="0"/>
+              <a:t>- event architecture </a:t>
+            </a:r>
+            <a:endParaRPr lang="en-GB" b="1" dirty="0"/>
+          </a:p>
+        </p:txBody>
+      </p:sp>
+    </p:spTree>
+    <p:extLst>
+      <p:ext uri="{BB962C8B-B14F-4D97-AF65-F5344CB8AC3E}">
+        <p14:creationId xmlns:p14="http://schemas.microsoft.com/office/powerpoint/2010/main" val="3479991794"/>
+      </p:ext>
+    </p:extLst>
+  </p:cSld>
+  <p:clrMapOvr>
+    <a:masterClrMapping/>
+  </p:clrMapOvr>
+</p:sld>
+</file>
+
+<file path=ppt/slides/slide12.xml><?xml version="1.0" encoding="utf-8"?>
+<p:sld xmlns:a="http://schemas.openxmlformats.org/drawingml/2006/main" xmlns:r="http://schemas.openxmlformats.org/officeDocument/2006/relationships" xmlns:p="http://schemas.openxmlformats.org/presentationml/2006/main">
+  <p:cSld>
+    <p:spTree>
+      <p:nvGrpSpPr>
+        <p:cNvPr id="1" name=""/>
+        <p:cNvGrpSpPr/>
+        <p:nvPr/>
+      </p:nvGrpSpPr>
+      <p:grpSpPr>
+        <a:xfrm>
+          <a:off x="0" y="0"/>
+          <a:ext cx="0" cy="0"/>
+          <a:chOff x="0" y="0"/>
+          <a:chExt cx="0" cy="0"/>
+        </a:xfrm>
+      </p:grpSpPr>
+      <p:sp>
+        <p:nvSpPr>
+          <p:cNvPr id="2" name="Title 1">
+            <a:extLst>
+              <a:ext uri="{FF2B5EF4-FFF2-40B4-BE49-F238E27FC236}">
+                <a16:creationId xmlns:a16="http://schemas.microsoft.com/office/drawing/2014/main" id="{1CC34D4E-B377-97A4-8B38-9884B94EA691}"/>
+              </a:ext>
+            </a:extLst>
+          </p:cNvPr>
+          <p:cNvSpPr>
+            <a:spLocks noGrp="1"/>
+          </p:cNvSpPr>
+          <p:nvPr>
+            <p:ph type="title"/>
+          </p:nvPr>
+        </p:nvSpPr>
+        <p:spPr/>
+        <p:txBody>
+          <a:bodyPr/>
+          <a:lstStyle/>
+          <a:p>
+            <a:r>
+              <a:rPr lang="en-US" dirty="0"/>
+              <a:t>My vision for the final version of my project</a:t>
+            </a:r>
+            <a:endParaRPr lang="en-GB" dirty="0"/>
+          </a:p>
+        </p:txBody>
+      </p:sp>
+      <p:sp>
+        <p:nvSpPr>
+          <p:cNvPr id="3" name="Content Placeholder 2">
+            <a:extLst>
+              <a:ext uri="{FF2B5EF4-FFF2-40B4-BE49-F238E27FC236}">
+                <a16:creationId xmlns:a16="http://schemas.microsoft.com/office/drawing/2014/main" id="{3133708C-A77D-63CB-FFDE-68FE5E3D28A4}"/>
+              </a:ext>
+            </a:extLst>
+          </p:cNvPr>
+          <p:cNvSpPr>
+            <a:spLocks noGrp="1"/>
+          </p:cNvSpPr>
+          <p:nvPr>
+            <p:ph idx="1"/>
+          </p:nvPr>
+        </p:nvSpPr>
+        <p:spPr/>
+        <p:txBody>
+          <a:bodyPr/>
+          <a:lstStyle/>
+          <a:p>
+            <a:r>
+              <a:rPr lang="en-US" dirty="0"/>
+              <a:t>An RTS game that supports any game length</a:t>
+            </a:r>
+            <a:r>
+              <a:rPr lang="en-GB" dirty="0"/>
+              <a:t> with no significant slow down regardless of how long a given game is played for </a:t>
+            </a:r>
+          </a:p>
+          <a:p>
+            <a:r>
+              <a:rPr lang="en-GB" dirty="0"/>
+              <a:t>Seamless split screen implementation that allows for a user to disconnect or reconnect at any time then resume where they left off</a:t>
+            </a:r>
+          </a:p>
+          <a:p>
+            <a:r>
+              <a:rPr lang="en-GB" dirty="0"/>
+              <a:t>Feature rich interaction between users happening in real time with no delay</a:t>
+            </a:r>
+          </a:p>
+          <a:p>
+            <a:pPr marL="0" indent="0">
+              <a:buNone/>
+            </a:pPr>
+            <a:endParaRPr lang="en-US" dirty="0"/>
+          </a:p>
+        </p:txBody>
+      </p:sp>
+    </p:spTree>
+    <p:extLst>
+      <p:ext uri="{BB962C8B-B14F-4D97-AF65-F5344CB8AC3E}">
+        <p14:creationId xmlns:p14="http://schemas.microsoft.com/office/powerpoint/2010/main" val="268863310"/>
       </p:ext>
     </p:extLst>
   </p:cSld>
@@ -3443,7 +3754,7 @@
           <p:cNvPr id="2" name="Title 1">
             <a:extLst>
               <a:ext uri="{FF2B5EF4-FFF2-40B4-BE49-F238E27FC236}">
-                <a16:creationId xmlns:a16="http://schemas.microsoft.com/office/drawing/2014/main" id="{A38F2100-9E31-C725-4173-D6551AFD5E5E}"/>
+                <a16:creationId xmlns:a16="http://schemas.microsoft.com/office/drawing/2014/main" id="{8E2E6D9F-D07D-4740-DECB-C42A64056C85}"/>
               </a:ext>
             </a:extLst>
           </p:cNvPr>
@@ -3461,7 +3772,7 @@
           <a:p>
             <a:r>
               <a:rPr lang="en-US" dirty="0"/>
-              <a:t>An overview of my project</a:t>
+              <a:t>Why concurrency matters in game development</a:t>
             </a:r>
             <a:endParaRPr lang="en-GB" dirty="0"/>
           </a:p>
@@ -3472,7 +3783,7 @@
           <p:cNvPr id="3" name="Content Placeholder 2">
             <a:extLst>
               <a:ext uri="{FF2B5EF4-FFF2-40B4-BE49-F238E27FC236}">
-                <a16:creationId xmlns:a16="http://schemas.microsoft.com/office/drawing/2014/main" id="{7AB659AF-1579-F262-D689-CB5D6F1EDE66}"/>
+                <a16:creationId xmlns:a16="http://schemas.microsoft.com/office/drawing/2014/main" id="{ACBAA111-6C11-C444-9DC0-D077CA4F067A}"/>
               </a:ext>
             </a:extLst>
           </p:cNvPr>
@@ -3489,37 +3800,43 @@
           <a:lstStyle/>
           <a:p>
             <a:r>
+              <a:rPr lang="en-US" b="1" dirty="0"/>
+              <a:t>Responsiveness</a:t>
+            </a:r>
+            <a:r>
               <a:rPr lang="en-US" dirty="0"/>
-              <a:t>Written fully in </a:t>
-            </a:r>
-            <a:r>
-              <a:rPr lang="en-US" dirty="0" err="1"/>
-              <a:t>c++</a:t>
+              <a:t>: Keeps UI and input smooth during performance-intensive operations</a:t>
+            </a:r>
+          </a:p>
+          <a:p>
+            <a:r>
+              <a:rPr lang="en-US" b="1" dirty="0"/>
+              <a:t>Performance</a:t>
             </a:r>
             <a:r>
               <a:rPr lang="en-US" dirty="0"/>
-              <a:t> with Ogre3d as the primary renderer</a:t>
-            </a:r>
-          </a:p>
-          <a:p>
+              <a:t>: Parallelizes game logic across threads for faster execution</a:t>
+            </a:r>
+          </a:p>
+          <a:p>
+            <a:r>
+              <a:rPr lang="en-US" b="1" dirty="0"/>
+              <a:t>Hardware Utilization</a:t>
+            </a:r>
             <a:r>
               <a:rPr lang="en-US" dirty="0"/>
-              <a:t>Full concurrency focus with multiple users at the same time</a:t>
-            </a:r>
-          </a:p>
-          <a:p>
+              <a:t>: Leverages modern multi-core CPUs that would otherwise sit idle</a:t>
+            </a:r>
+          </a:p>
+          <a:p>
+            <a:r>
+              <a:rPr lang="en-US" b="1" dirty="0"/>
+              <a:t>Scalability</a:t>
+            </a:r>
             <a:r>
               <a:rPr lang="en-US" dirty="0"/>
-              <a:t>Event driven architecture with event queues</a:t>
-            </a:r>
-          </a:p>
-          <a:p>
-            <a:r>
-              <a:rPr lang="en-US" dirty="0"/>
-              <a:t>ECS for game object storage</a:t>
-            </a:r>
-          </a:p>
-          <a:p>
+              <a:t>: Enables games to handle more entities, complex AI, and detailed physics simulations simultaneously</a:t>
+            </a:r>
             <a:endParaRPr lang="en-GB" dirty="0"/>
           </a:p>
         </p:txBody>
@@ -3527,7 +3844,7 @@
     </p:spTree>
     <p:extLst>
       <p:ext uri="{BB962C8B-B14F-4D97-AF65-F5344CB8AC3E}">
-        <p14:creationId xmlns:p14="http://schemas.microsoft.com/office/powerpoint/2010/main" val="3562178587"/>
+        <p14:creationId xmlns:p14="http://schemas.microsoft.com/office/powerpoint/2010/main" val="2791909652"/>
       </p:ext>
     </p:extLst>
   </p:cSld>
@@ -3559,7 +3876,7 @@
           <p:cNvPr id="2" name="Title 1">
             <a:extLst>
               <a:ext uri="{FF2B5EF4-FFF2-40B4-BE49-F238E27FC236}">
-                <a16:creationId xmlns:a16="http://schemas.microsoft.com/office/drawing/2014/main" id="{222F46F9-E139-2D9E-B524-56ACEAFD482C}"/>
+                <a16:creationId xmlns:a16="http://schemas.microsoft.com/office/drawing/2014/main" id="{EF0A3931-18B6-C022-412D-D9556F471522}"/>
               </a:ext>
             </a:extLst>
           </p:cNvPr>
@@ -3577,7 +3894,7 @@
           <a:p>
             <a:r>
               <a:rPr lang="en-US" dirty="0"/>
-              <a:t>Why Ogre3d and how am I using it?</a:t>
+              <a:t>An overview of my project</a:t>
             </a:r>
             <a:endParaRPr lang="en-GB" dirty="0"/>
           </a:p>
@@ -3588,7 +3905,7 @@
           <p:cNvPr id="3" name="Content Placeholder 2">
             <a:extLst>
               <a:ext uri="{FF2B5EF4-FFF2-40B4-BE49-F238E27FC236}">
-                <a16:creationId xmlns:a16="http://schemas.microsoft.com/office/drawing/2014/main" id="{0182E657-D8AF-4756-8682-828B57AA357D}"/>
+                <a16:creationId xmlns:a16="http://schemas.microsoft.com/office/drawing/2014/main" id="{D7E4F512-C0E6-D180-A685-5F0C8A9C99CD}"/>
               </a:ext>
             </a:extLst>
           </p:cNvPr>
@@ -3604,14 +3921,76 @@
           <a:bodyPr/>
           <a:lstStyle/>
           <a:p>
-            <a:endParaRPr lang="en-GB"/>
+            <a:r>
+              <a:rPr lang="en-US" b="1" dirty="0"/>
+              <a:t>Genre</a:t>
+            </a:r>
+            <a:r>
+              <a:rPr lang="en-US" dirty="0"/>
+              <a:t>: Real-time strategy with split-screen multiplayer</a:t>
+            </a:r>
+          </a:p>
+          <a:p>
+            <a:r>
+              <a:rPr lang="en-US" b="1" dirty="0"/>
+              <a:t>Country based: </a:t>
+            </a:r>
+            <a:r>
+              <a:rPr lang="en-US" dirty="0"/>
+              <a:t>the classic strategy formula of multiple countries competing with </a:t>
+            </a:r>
+            <a:r>
+              <a:rPr lang="en-US" dirty="0" err="1"/>
+              <a:t>eachother</a:t>
+            </a:r>
+            <a:r>
+              <a:rPr lang="en-US" dirty="0"/>
+              <a:t> </a:t>
+            </a:r>
+            <a:endParaRPr lang="en-US" b="1" dirty="0"/>
+          </a:p>
+          <a:p>
+            <a:r>
+              <a:rPr lang="en-US" b="1" dirty="0"/>
+              <a:t>Performance focus: </a:t>
+            </a:r>
+            <a:r>
+              <a:rPr lang="en-US" dirty="0" err="1"/>
+              <a:t>optimised</a:t>
+            </a:r>
+            <a:r>
+              <a:rPr lang="en-US" dirty="0"/>
+              <a:t> for longer games with more units on the screen</a:t>
+            </a:r>
+            <a:endParaRPr lang="en-US" b="1" dirty="0"/>
+          </a:p>
+          <a:p>
+            <a:r>
+              <a:rPr lang="en-US" b="1" dirty="0"/>
+              <a:t>Local Multiplayer</a:t>
+            </a:r>
+            <a:r>
+              <a:rPr lang="en-US" dirty="0"/>
+              <a:t>: Supports up to 5 players (1 keyboard + 4 controllers)</a:t>
+            </a:r>
+          </a:p>
+          <a:p>
+            <a:r>
+              <a:rPr lang="en-US" b="1" dirty="0"/>
+              <a:t>Split screen with birds eye view: </a:t>
+            </a:r>
+            <a:r>
+              <a:rPr lang="en-US" dirty="0"/>
+              <a:t>each player has a dedicated portion of the screen with a bird's eye view of the game world</a:t>
+            </a:r>
+            <a:endParaRPr lang="en-US" b="1" dirty="0"/>
           </a:p>
         </p:txBody>
       </p:sp>
     </p:spTree>
     <p:extLst>
       <p:ext uri="{BB962C8B-B14F-4D97-AF65-F5344CB8AC3E}">
-        <p14:creationId xmlns:p14="http://schemas.microsoft.com/office/powerpoint/2010/main" val="557499388"/>
+        <p14:creationId xmlns:p14="http://schemas.microsoft.com/office/powerpoint/2010/main" val="2344679657"/>
       </p:ext>
     </p:extLst>
   </p:cSld>
@@ -3643,7 +4022,7 @@
           <p:cNvPr id="2" name="Title 1">
             <a:extLst>
               <a:ext uri="{FF2B5EF4-FFF2-40B4-BE49-F238E27FC236}">
-                <a16:creationId xmlns:a16="http://schemas.microsoft.com/office/drawing/2014/main" id="{DF8A3BB7-C438-DECA-C25B-5F7D57F57E8B}"/>
+                <a16:creationId xmlns:a16="http://schemas.microsoft.com/office/drawing/2014/main" id="{A38F2100-9E31-C725-4173-D6551AFD5E5E}"/>
               </a:ext>
             </a:extLst>
           </p:cNvPr>
@@ -3661,7 +4040,7 @@
           <a:p>
             <a:r>
               <a:rPr lang="en-US" dirty="0"/>
-              <a:t>why ECS and how am I using it?</a:t>
+              <a:t>The technical aspects of my project</a:t>
             </a:r>
             <a:endParaRPr lang="en-GB" dirty="0"/>
           </a:p>
@@ -3672,7 +4051,7 @@
           <p:cNvPr id="3" name="Content Placeholder 2">
             <a:extLst>
               <a:ext uri="{FF2B5EF4-FFF2-40B4-BE49-F238E27FC236}">
-                <a16:creationId xmlns:a16="http://schemas.microsoft.com/office/drawing/2014/main" id="{B37749E8-D7CA-7FE2-0AE1-40F3CA8CEA60}"/>
+                <a16:creationId xmlns:a16="http://schemas.microsoft.com/office/drawing/2014/main" id="{7AB659AF-1579-F262-D689-CB5D6F1EDE66}"/>
               </a:ext>
             </a:extLst>
           </p:cNvPr>
@@ -3683,19 +4062,84 @@
             <p:ph idx="1"/>
           </p:nvPr>
         </p:nvSpPr>
-        <p:spPr/>
-        <p:txBody>
-          <a:bodyPr/>
-          <a:lstStyle/>
-          <a:p>
-            <a:endParaRPr lang="en-GB"/>
+        <p:spPr>
+          <a:xfrm>
+            <a:off x="504265" y="1351429"/>
+            <a:ext cx="11268635" cy="5372100"/>
+          </a:xfrm>
+        </p:spPr>
+        <p:txBody>
+          <a:bodyPr>
+            <a:normAutofit/>
+          </a:bodyPr>
+          <a:lstStyle/>
+          <a:p>
+            <a:r>
+              <a:rPr lang="en-US" b="1" dirty="0"/>
+              <a:t>Programming language: </a:t>
+            </a:r>
+            <a:r>
+              <a:rPr lang="en-US" dirty="0"/>
+              <a:t>C++</a:t>
+            </a:r>
+          </a:p>
+          <a:p>
+            <a:r>
+              <a:rPr lang="en-US" b="1" dirty="0"/>
+              <a:t>Graphics engine: </a:t>
+            </a:r>
+            <a:r>
+              <a:rPr lang="en-US" dirty="0"/>
+              <a:t>Ogre3d</a:t>
+            </a:r>
+          </a:p>
+          <a:p>
+            <a:r>
+              <a:rPr lang="en-US" b="1" dirty="0"/>
+              <a:t>Concurrency focus: </a:t>
+            </a:r>
+            <a:r>
+              <a:rPr lang="en-US" dirty="0"/>
+              <a:t>each player has their own game instance running simultaneously using threads</a:t>
+            </a:r>
+          </a:p>
+          <a:p>
+            <a:r>
+              <a:rPr lang="en-US" b="1" dirty="0"/>
+              <a:t>Event architecture: </a:t>
+            </a:r>
+            <a:r>
+              <a:rPr lang="en-US" dirty="0"/>
+              <a:t>game instances communicate using events in conjunction with event queues to avoid race conditions</a:t>
+            </a:r>
+          </a:p>
+          <a:p>
+            <a:r>
+              <a:rPr lang="en-US" b="1" dirty="0"/>
+              <a:t>Entity storage: </a:t>
+            </a:r>
+            <a:r>
+              <a:rPr lang="en-US" dirty="0"/>
+              <a:t>ECS (entity component system) used for both storage and managing modular behavior of entities</a:t>
+            </a:r>
+          </a:p>
+          <a:p>
+            <a:r>
+              <a:rPr lang="en-US" b="1" dirty="0"/>
+              <a:t>Input handling: </a:t>
+            </a:r>
+            <a:r>
+              <a:rPr lang="en-US" dirty="0"/>
+              <a:t>SDL2 (software direct media layer) to read and distinguish multiple input devices</a:t>
+            </a:r>
+            <a:endParaRPr lang="en-US" b="1" dirty="0"/>
           </a:p>
         </p:txBody>
       </p:sp>
     </p:spTree>
     <p:extLst>
       <p:ext uri="{BB962C8B-B14F-4D97-AF65-F5344CB8AC3E}">
-        <p14:creationId xmlns:p14="http://schemas.microsoft.com/office/powerpoint/2010/main" val="3916104791"/>
+        <p14:creationId xmlns:p14="http://schemas.microsoft.com/office/powerpoint/2010/main" val="3562178587"/>
       </p:ext>
     </p:extLst>
   </p:cSld>
@@ -3727,7 +4171,7 @@
           <p:cNvPr id="2" name="Title 1">
             <a:extLst>
               <a:ext uri="{FF2B5EF4-FFF2-40B4-BE49-F238E27FC236}">
-                <a16:creationId xmlns:a16="http://schemas.microsoft.com/office/drawing/2014/main" id="{750A3C54-C49F-D134-6034-E4A332016B7F}"/>
+                <a16:creationId xmlns:a16="http://schemas.microsoft.com/office/drawing/2014/main" id="{1F0E351C-5813-7CE5-BB49-770C13723EAB}"/>
               </a:ext>
             </a:extLst>
           </p:cNvPr>
@@ -3745,45 +4189,158 @@
           <a:p>
             <a:r>
               <a:rPr lang="en-US" dirty="0"/>
-              <a:t>Where does concurrency fit in to </a:t>
-            </a:r>
-            <a:r>
-              <a:rPr lang="en-US"/>
-              <a:t>all this?</a:t>
-            </a:r>
-            <a:endParaRPr lang="en-GB"/>
-          </a:p>
-        </p:txBody>
-      </p:sp>
-      <p:sp>
-        <p:nvSpPr>
-          <p:cNvPr id="3" name="Content Placeholder 2">
-            <a:extLst>
-              <a:ext uri="{FF2B5EF4-FFF2-40B4-BE49-F238E27FC236}">
-                <a16:creationId xmlns:a16="http://schemas.microsoft.com/office/drawing/2014/main" id="{41B31B05-380E-BA83-89CC-1CEEF1416403}"/>
-              </a:ext>
-            </a:extLst>
-          </p:cNvPr>
-          <p:cNvSpPr>
-            <a:spLocks noGrp="1"/>
-          </p:cNvSpPr>
+              <a:t>What’s already implemented?</a:t>
+            </a:r>
+            <a:endParaRPr lang="en-GB" dirty="0"/>
+          </a:p>
+        </p:txBody>
+      </p:sp>
+      <p:pic>
+        <p:nvPicPr>
+          <p:cNvPr id="5" name="Content Placeholder 4">
+            <a:extLst>
+              <a:ext uri="{FF2B5EF4-FFF2-40B4-BE49-F238E27FC236}">
+                <a16:creationId xmlns:a16="http://schemas.microsoft.com/office/drawing/2014/main" id="{D2977087-9E1F-3EF7-AFC3-B6BB1DFFF060}"/>
+              </a:ext>
+            </a:extLst>
+          </p:cNvPr>
+          <p:cNvPicPr>
+            <a:picLocks noGrp="1" noChangeAspect="1"/>
+          </p:cNvPicPr>
           <p:nvPr>
             <p:ph idx="1"/>
           </p:nvPr>
-        </p:nvSpPr>
-        <p:spPr/>
-        <p:txBody>
-          <a:bodyPr/>
-          <a:lstStyle/>
-          <a:p>
-            <a:endParaRPr lang="en-GB"/>
+        </p:nvPicPr>
+        <p:blipFill>
+          <a:blip r:embed="rId2"/>
+          <a:stretch>
+            <a:fillRect/>
+          </a:stretch>
+        </p:blipFill>
+        <p:spPr>
+          <a:xfrm>
+            <a:off x="60513" y="1690688"/>
+            <a:ext cx="6193990" cy="3553665"/>
+          </a:xfrm>
+          <a:prstGeom prst="rect">
+            <a:avLst/>
+          </a:prstGeom>
+        </p:spPr>
+      </p:pic>
+      <p:sp>
+        <p:nvSpPr>
+          <p:cNvPr id="6" name="TextBox 5">
+            <a:extLst>
+              <a:ext uri="{FF2B5EF4-FFF2-40B4-BE49-F238E27FC236}">
+                <a16:creationId xmlns:a16="http://schemas.microsoft.com/office/drawing/2014/main" id="{CDAF71B0-ABC0-C6BE-2E0A-41A1447A19F2}"/>
+              </a:ext>
+            </a:extLst>
+          </p:cNvPr>
+          <p:cNvSpPr txBox="1"/>
+          <p:nvPr/>
+        </p:nvSpPr>
+        <p:spPr>
+          <a:xfrm>
+            <a:off x="6225125" y="1320494"/>
+            <a:ext cx="6017559" cy="5170646"/>
+          </a:xfrm>
+          <a:prstGeom prst="rect">
+            <a:avLst/>
+          </a:prstGeom>
+          <a:noFill/>
+        </p:spPr>
+        <p:txBody>
+          <a:bodyPr wrap="square" rtlCol="0">
+            <a:spAutoFit/>
+          </a:bodyPr>
+          <a:lstStyle/>
+          <a:p>
+            <a:pPr marL="285750" indent="-285750">
+              <a:buFontTx/>
+              <a:buChar char="-"/>
+            </a:pPr>
+            <a:r>
+              <a:rPr lang="en-US" sz="2400" b="1" dirty="0"/>
+              <a:t>Input handling: </a:t>
+            </a:r>
+            <a:r>
+              <a:rPr lang="en-US" sz="2400" dirty="0"/>
+              <a:t>all devices currently plugged in are recognized and read</a:t>
+            </a:r>
+            <a:endParaRPr lang="en-US" sz="2400" b="1" dirty="0"/>
+          </a:p>
+          <a:p>
+            <a:pPr marL="285750" indent="-285750">
+              <a:buFontTx/>
+              <a:buChar char="-"/>
+            </a:pPr>
+            <a:r>
+              <a:rPr lang="en-US" sz="2400" b="1" dirty="0"/>
+              <a:t>Split screen: </a:t>
+            </a:r>
+            <a:r>
+              <a:rPr lang="en-US" sz="2400" dirty="0"/>
+              <a:t>Each input device is assigned a portion of the screen </a:t>
+            </a:r>
+          </a:p>
+          <a:p>
+            <a:pPr marL="285750" indent="-285750">
+              <a:buFontTx/>
+              <a:buChar char="-"/>
+            </a:pPr>
+            <a:r>
+              <a:rPr lang="en-US" sz="2400" b="1" dirty="0"/>
+              <a:t>Disconnect handling: </a:t>
+            </a:r>
+            <a:r>
+              <a:rPr lang="en-US" sz="2400" dirty="0"/>
+              <a:t>controllers that are unplugged are automatically reconnected to the correct game instance once plugged back in</a:t>
+            </a:r>
+            <a:endParaRPr lang="en-US" sz="2400" b="1" dirty="0"/>
+          </a:p>
+          <a:p>
+            <a:pPr marL="285750" indent="-285750">
+              <a:buFontTx/>
+              <a:buChar char="-"/>
+            </a:pPr>
+            <a:r>
+              <a:rPr lang="en-US" sz="2400" b="1" dirty="0"/>
+              <a:t>Separate camera control: </a:t>
+            </a:r>
+            <a:r>
+              <a:rPr lang="en-US" sz="2400" dirty="0"/>
+              <a:t>each device controls the perspective on the assigned portion of the screen</a:t>
+            </a:r>
+            <a:endParaRPr lang="en-US" sz="2400" b="1" dirty="0"/>
+          </a:p>
+          <a:p>
+            <a:pPr marL="285750" indent="-285750">
+              <a:buFontTx/>
+              <a:buChar char="-"/>
+            </a:pPr>
+            <a:r>
+              <a:rPr lang="en-US" sz="2400" b="1" dirty="0"/>
+              <a:t>Entity storage: </a:t>
+            </a:r>
+            <a:r>
+              <a:rPr lang="en-US" sz="2400" dirty="0"/>
+              <a:t>the cube visible on the screen is stored using ECS</a:t>
+            </a:r>
+            <a:endParaRPr lang="en-US" sz="2400" b="1" dirty="0"/>
+          </a:p>
+          <a:p>
+            <a:pPr marL="285750" indent="-285750">
+              <a:buFontTx/>
+              <a:buChar char="-"/>
+            </a:pPr>
+            <a:endParaRPr lang="en-GB" dirty="0"/>
           </a:p>
         </p:txBody>
       </p:sp>
     </p:spTree>
     <p:extLst>
       <p:ext uri="{BB962C8B-B14F-4D97-AF65-F5344CB8AC3E}">
-        <p14:creationId xmlns:p14="http://schemas.microsoft.com/office/powerpoint/2010/main" val="620915863"/>
+        <p14:creationId xmlns:p14="http://schemas.microsoft.com/office/powerpoint/2010/main" val="1464994183"/>
       </p:ext>
     </p:extLst>
   </p:cSld>
@@ -3815,7 +4372,7 @@
           <p:cNvPr id="2" name="Title 1">
             <a:extLst>
               <a:ext uri="{FF2B5EF4-FFF2-40B4-BE49-F238E27FC236}">
-                <a16:creationId xmlns:a16="http://schemas.microsoft.com/office/drawing/2014/main" id="{8E2E6D9F-D07D-4740-DECB-C42A64056C85}"/>
+                <a16:creationId xmlns:a16="http://schemas.microsoft.com/office/drawing/2014/main" id="{63428104-876E-E9FC-4A7F-E152A0C8AECF}"/>
               </a:ext>
             </a:extLst>
           </p:cNvPr>
@@ -3833,7 +4390,7 @@
           <a:p>
             <a:r>
               <a:rPr lang="en-US" dirty="0"/>
-              <a:t>Why did I decide on this project?</a:t>
+              <a:t>Major technologies I’ve used - ECS</a:t>
             </a:r>
             <a:endParaRPr lang="en-GB" dirty="0"/>
           </a:p>
@@ -3844,7 +4401,7 @@
           <p:cNvPr id="3" name="Content Placeholder 2">
             <a:extLst>
               <a:ext uri="{FF2B5EF4-FFF2-40B4-BE49-F238E27FC236}">
-                <a16:creationId xmlns:a16="http://schemas.microsoft.com/office/drawing/2014/main" id="{ACBAA111-6C11-C444-9DC0-D077CA4F067A}"/>
+                <a16:creationId xmlns:a16="http://schemas.microsoft.com/office/drawing/2014/main" id="{726E14D4-3F41-0DB1-6EEC-800507D5C0CB}"/>
               </a:ext>
             </a:extLst>
           </p:cNvPr>
@@ -3855,29 +4412,138 @@
             <p:ph idx="1"/>
           </p:nvPr>
         </p:nvSpPr>
-        <p:spPr/>
-        <p:txBody>
-          <a:bodyPr/>
-          <a:lstStyle/>
-          <a:p>
+        <p:spPr>
+          <a:xfrm>
+            <a:off x="176719" y="1845080"/>
+            <a:ext cx="5257800" cy="4351338"/>
+          </a:xfrm>
+        </p:spPr>
+        <p:txBody>
+          <a:bodyPr/>
+          <a:lstStyle/>
+          <a:p>
+            <a:pPr marL="0" indent="0">
+              <a:buNone/>
+            </a:pPr>
             <a:r>
               <a:rPr lang="en-US" dirty="0"/>
-              <a:t>True local multiplayer is rare, especially in the RTS genre</a:t>
-            </a:r>
-          </a:p>
-          <a:p>
-            <a:r>
+              <a:t>	</a:t>
+            </a:r>
+            <a:r>
+              <a:rPr lang="en-US" b="1" dirty="0"/>
+              <a:t>What is ECS?</a:t>
+            </a:r>
+            <a:br>
               <a:rPr lang="en-US" dirty="0"/>
-              <a:t>Current solutions to the problems I am tackling encounter significant performance issues</a:t>
-            </a:r>
-          </a:p>
-          <a:p>
-            <a:r>
+            </a:br>
+            <a:br>
               <a:rPr lang="en-US" dirty="0"/>
-              <a:t>RTS is an ideal scenario for a concurrent environment</a:t>
-            </a:r>
-          </a:p>
-          <a:p>
+            </a:br>
+            <a:r>
+              <a:rPr lang="en-US" dirty="0"/>
+              <a:t>- ECS (entity component system) is a method of </a:t>
+            </a:r>
+            <a:r>
+              <a:rPr lang="en-US"/>
+              <a:t>storing data, </a:t>
+            </a:r>
+            <a:r>
+              <a:rPr lang="en-US" dirty="0"/>
+              <a:t>separated into entities</a:t>
+            </a:r>
+          </a:p>
+          <a:p>
+            <a:pPr marL="0" indent="0">
+              <a:buNone/>
+            </a:pPr>
+            <a:r>
+              <a:rPr lang="en-US" dirty="0"/>
+              <a:t>- Each entity is separated into components which can be added or removed at any time</a:t>
+            </a:r>
+            <a:br>
+              <a:rPr lang="en-US" dirty="0"/>
+            </a:br>
+            <a:endParaRPr lang="en-GB" dirty="0"/>
+          </a:p>
+        </p:txBody>
+      </p:sp>
+      <p:sp>
+        <p:nvSpPr>
+          <p:cNvPr id="4" name="TextBox 3">
+            <a:extLst>
+              <a:ext uri="{FF2B5EF4-FFF2-40B4-BE49-F238E27FC236}">
+                <a16:creationId xmlns:a16="http://schemas.microsoft.com/office/drawing/2014/main" id="{8F77F3C4-960D-BC81-6AB2-FE1F402F9712}"/>
+              </a:ext>
+            </a:extLst>
+          </p:cNvPr>
+          <p:cNvSpPr txBox="1"/>
+          <p:nvPr/>
+        </p:nvSpPr>
+        <p:spPr>
+          <a:xfrm>
+            <a:off x="5492885" y="1845080"/>
+            <a:ext cx="6355404" cy="4401205"/>
+          </a:xfrm>
+          <a:prstGeom prst="rect">
+            <a:avLst/>
+          </a:prstGeom>
+          <a:noFill/>
+        </p:spPr>
+        <p:txBody>
+          <a:bodyPr wrap="square" rtlCol="0">
+            <a:spAutoFit/>
+          </a:bodyPr>
+          <a:lstStyle/>
+          <a:p>
+            <a:r>
+              <a:rPr lang="en-US" dirty="0"/>
+              <a:t>	</a:t>
+            </a:r>
+            <a:r>
+              <a:rPr lang="en-US" sz="2800" dirty="0"/>
+              <a:t>	</a:t>
+            </a:r>
+            <a:r>
+              <a:rPr lang="en-US" sz="2800" b="1" dirty="0"/>
+              <a:t>why ECS?</a:t>
+            </a:r>
+            <a:br>
+              <a:rPr lang="en-US" sz="2800" b="1" dirty="0"/>
+            </a:br>
+            <a:r>
+              <a:rPr lang="en-US" sz="2800" dirty="0"/>
+              <a:t>- </a:t>
+            </a:r>
+            <a:r>
+              <a:rPr lang="en-US" sz="2800" b="1" dirty="0"/>
+              <a:t> </a:t>
+            </a:r>
+            <a:r>
+              <a:rPr lang="en-US" sz="2800" dirty="0"/>
+              <a:t>time complexity of O(1) for component and entity operations</a:t>
+            </a:r>
+            <a:br>
+              <a:rPr lang="en-US" sz="2800" dirty="0"/>
+            </a:br>
+            <a:r>
+              <a:rPr lang="en-US" sz="2800" dirty="0"/>
+              <a:t>- entities can be grouped together, allowing similar entities to be stored contiguously </a:t>
+            </a:r>
+            <a:br>
+              <a:rPr lang="en-US" sz="2800" dirty="0"/>
+            </a:br>
+            <a:r>
+              <a:rPr lang="en-US" sz="2800" dirty="0"/>
+              <a:t>- extremely useful for my project, each game “unit” can easily have </a:t>
+            </a:r>
+            <a:r>
+              <a:rPr lang="en-US" sz="2800" dirty="0" err="1"/>
+              <a:t>behaviour</a:t>
+            </a:r>
+            <a:r>
+              <a:rPr lang="en-US" sz="2800" dirty="0"/>
+              <a:t> added or removed to it based on its components</a:t>
+            </a:r>
             <a:endParaRPr lang="en-GB" dirty="0"/>
           </a:p>
         </p:txBody>
@@ -3885,7 +4551,7 @@
     </p:spTree>
     <p:extLst>
       <p:ext uri="{BB962C8B-B14F-4D97-AF65-F5344CB8AC3E}">
-        <p14:creationId xmlns:p14="http://schemas.microsoft.com/office/powerpoint/2010/main" val="2791909652"/>
+        <p14:creationId xmlns:p14="http://schemas.microsoft.com/office/powerpoint/2010/main" val="3989243193"/>
       </p:ext>
     </p:extLst>
   </p:cSld>
@@ -3917,7 +4583,7 @@
           <p:cNvPr id="2" name="Title 1">
             <a:extLst>
               <a:ext uri="{FF2B5EF4-FFF2-40B4-BE49-F238E27FC236}">
-                <a16:creationId xmlns:a16="http://schemas.microsoft.com/office/drawing/2014/main" id="{9D38466A-51EC-B1F8-8C58-25FA9C91A876}"/>
+                <a16:creationId xmlns:a16="http://schemas.microsoft.com/office/drawing/2014/main" id="{9A4ED057-1A76-43BD-4580-9F7184073BFB}"/>
               </a:ext>
             </a:extLst>
           </p:cNvPr>
@@ -3935,7 +4601,7 @@
           <a:p>
             <a:r>
               <a:rPr lang="en-US" dirty="0"/>
-              <a:t>What is the current state of my project?</a:t>
+              <a:t>example of how I use ECS in my project</a:t>
             </a:r>
             <a:endParaRPr lang="en-GB" dirty="0"/>
           </a:p>
@@ -3946,7 +4612,7 @@
           <p:cNvPr id="3" name="Content Placeholder 2">
             <a:extLst>
               <a:ext uri="{FF2B5EF4-FFF2-40B4-BE49-F238E27FC236}">
-                <a16:creationId xmlns:a16="http://schemas.microsoft.com/office/drawing/2014/main" id="{C3EEAC57-9E73-9070-9ADB-667E5F3D45BB}"/>
+                <a16:creationId xmlns:a16="http://schemas.microsoft.com/office/drawing/2014/main" id="{DB443C9A-1B25-BA2F-EF0D-ACCECCBC688D}"/>
               </a:ext>
             </a:extLst>
           </p:cNvPr>
@@ -3957,35 +4623,67 @@
             <p:ph idx="1"/>
           </p:nvPr>
         </p:nvSpPr>
-        <p:spPr/>
-        <p:txBody>
-          <a:bodyPr/>
-          <a:lstStyle/>
-          <a:p>
+        <p:spPr>
+          <a:xfrm>
+            <a:off x="1207851" y="1561777"/>
+            <a:ext cx="4174787" cy="1650392"/>
+          </a:xfrm>
+        </p:spPr>
+        <p:txBody>
+          <a:bodyPr/>
+          <a:lstStyle/>
+          <a:p>
+            <a:pPr marL="0" indent="0">
+              <a:buNone/>
+            </a:pPr>
             <a:r>
               <a:rPr lang="en-US" dirty="0"/>
-              <a:t>Full concurrent input activity across multiple devices</a:t>
-            </a:r>
-          </a:p>
-          <a:p>
-            <a:r>
-              <a:rPr lang="en-US" dirty="0"/>
-              <a:t>Multiple game cameras with independent controls</a:t>
-            </a:r>
-          </a:p>
-          <a:p>
-            <a:r>
-              <a:rPr lang="en-US" dirty="0"/>
-              <a:t>complete groundwork for the future implementation of an RTS game</a:t>
+              <a:t>Creation of the example cube</a:t>
             </a:r>
             <a:endParaRPr lang="en-GB" dirty="0"/>
+          </a:p>
+        </p:txBody>
+      </p:sp>
+      <p:sp>
+        <p:nvSpPr>
+          <p:cNvPr id="4" name="TextBox 3">
+            <a:extLst>
+              <a:ext uri="{FF2B5EF4-FFF2-40B4-BE49-F238E27FC236}">
+                <a16:creationId xmlns:a16="http://schemas.microsoft.com/office/drawing/2014/main" id="{5D9D8501-6259-3DFF-FD8E-F273A202FB48}"/>
+              </a:ext>
+            </a:extLst>
+          </p:cNvPr>
+          <p:cNvSpPr txBox="1"/>
+          <p:nvPr/>
+        </p:nvSpPr>
+        <p:spPr>
+          <a:xfrm>
+            <a:off x="7665398" y="1561777"/>
+            <a:ext cx="3975371" cy="954107"/>
+          </a:xfrm>
+          <a:prstGeom prst="rect">
+            <a:avLst/>
+          </a:prstGeom>
+          <a:noFill/>
+        </p:spPr>
+        <p:txBody>
+          <a:bodyPr wrap="square" rtlCol="0">
+            <a:spAutoFit/>
+          </a:bodyPr>
+          <a:lstStyle/>
+          <a:p>
+            <a:r>
+              <a:rPr lang="en-US" sz="2800" dirty="0"/>
+              <a:t>The stored components of the cube</a:t>
+            </a:r>
+            <a:endParaRPr lang="en-GB" sz="2800" dirty="0"/>
           </a:p>
         </p:txBody>
       </p:sp>
     </p:spTree>
     <p:extLst>
       <p:ext uri="{BB962C8B-B14F-4D97-AF65-F5344CB8AC3E}">
-        <p14:creationId xmlns:p14="http://schemas.microsoft.com/office/powerpoint/2010/main" val="1106514468"/>
+        <p14:creationId xmlns:p14="http://schemas.microsoft.com/office/powerpoint/2010/main" val="3745132934"/>
       </p:ext>
     </p:extLst>
   </p:cSld>
@@ -4017,7 +4715,7 @@
           <p:cNvPr id="2" name="Title 1">
             <a:extLst>
               <a:ext uri="{FF2B5EF4-FFF2-40B4-BE49-F238E27FC236}">
-                <a16:creationId xmlns:a16="http://schemas.microsoft.com/office/drawing/2014/main" id="{1CC34D4E-B377-97A4-8B38-9884B94EA691}"/>
+                <a16:creationId xmlns:a16="http://schemas.microsoft.com/office/drawing/2014/main" id="{953F7429-34F6-0AB8-B55A-D1F166715553}"/>
               </a:ext>
             </a:extLst>
           </p:cNvPr>
@@ -4035,7 +4733,15 @@
           <a:p>
             <a:r>
               <a:rPr lang="en-US" dirty="0"/>
-              <a:t>My vision for the final version of my project</a:t>
+              <a:t>Major technologies </a:t>
+            </a:r>
+            <a:r>
+              <a:rPr lang="en-US" dirty="0" err="1"/>
+              <a:t>ive</a:t>
+            </a:r>
+            <a:r>
+              <a:rPr lang="en-US" dirty="0"/>
+              <a:t> used – SDL2</a:t>
             </a:r>
             <a:endParaRPr lang="en-GB" dirty="0"/>
           </a:p>
@@ -4046,7 +4752,7 @@
           <p:cNvPr id="3" name="Content Placeholder 2">
             <a:extLst>
               <a:ext uri="{FF2B5EF4-FFF2-40B4-BE49-F238E27FC236}">
-                <a16:creationId xmlns:a16="http://schemas.microsoft.com/office/drawing/2014/main" id="{3133708C-A77D-63CB-FFDE-68FE5E3D28A4}"/>
+                <a16:creationId xmlns:a16="http://schemas.microsoft.com/office/drawing/2014/main" id="{9E7E706C-D5D8-C6AB-669C-DD0BA3DD42B2}"/>
               </a:ext>
             </a:extLst>
           </p:cNvPr>
@@ -4057,44 +4763,480 @@
             <p:ph idx="1"/>
           </p:nvPr>
         </p:nvSpPr>
-        <p:spPr/>
-        <p:txBody>
-          <a:bodyPr/>
-          <a:lstStyle/>
-          <a:p>
+        <p:spPr>
+          <a:xfrm>
+            <a:off x="838200" y="1825625"/>
+            <a:ext cx="4233153" cy="4351338"/>
+          </a:xfrm>
+        </p:spPr>
+        <p:txBody>
+          <a:bodyPr/>
+          <a:lstStyle/>
+          <a:p>
+            <a:pPr marL="0" indent="0">
+              <a:buNone/>
+            </a:pPr>
+            <a:r>
+              <a:rPr lang="en-US" b="1" dirty="0"/>
+              <a:t>What is SDL2</a:t>
+            </a:r>
+          </a:p>
+          <a:p>
+            <a:pPr>
+              <a:buFontTx/>
+              <a:buChar char="-"/>
+            </a:pPr>
             <a:r>
               <a:rPr lang="en-US" dirty="0"/>
-              <a:t>An RTS game that supports any game length</a:t>
-            </a:r>
-            <a:r>
-              <a:rPr lang="en-GB" dirty="0"/>
-              <a:t> with no significant slow down regardless of how long a given game is played for </a:t>
-            </a:r>
-          </a:p>
-          <a:p>
-            <a:r>
-              <a:rPr lang="en-GB" dirty="0"/>
-              <a:t>Seamless split screen implementation that allows for a user to disconnect or reconnect at any time then resume where they left off</a:t>
-            </a:r>
-          </a:p>
-          <a:p>
-            <a:r>
-              <a:rPr lang="en-GB" dirty="0"/>
-              <a:t>Feature rich interaction between users happening in real time with no delay</a:t>
+              <a:t>SDL (simple direct media layer) is a </a:t>
+            </a:r>
+            <a:r>
+              <a:rPr lang="en-US" dirty="0" err="1"/>
+              <a:t>c++</a:t>
+            </a:r>
+            <a:r>
+              <a:rPr lang="en-US" dirty="0"/>
+              <a:t> library that provides a layer of abstraction to hardware. This allows it to read input from a variety of devices and isn’t platform specific</a:t>
             </a:r>
           </a:p>
           <a:p>
             <a:pPr marL="0" indent="0">
               <a:buNone/>
             </a:pPr>
+            <a:endParaRPr lang="en-GB" dirty="0"/>
+          </a:p>
+        </p:txBody>
+      </p:sp>
+      <p:sp>
+        <p:nvSpPr>
+          <p:cNvPr id="4" name="Content Placeholder 2">
+            <a:extLst>
+              <a:ext uri="{FF2B5EF4-FFF2-40B4-BE49-F238E27FC236}">
+                <a16:creationId xmlns:a16="http://schemas.microsoft.com/office/drawing/2014/main" id="{A5865011-889A-2537-AD4B-2F5C20B5FBBA}"/>
+              </a:ext>
+            </a:extLst>
+          </p:cNvPr>
+          <p:cNvSpPr txBox="1">
+            <a:spLocks/>
+          </p:cNvSpPr>
+          <p:nvPr/>
+        </p:nvSpPr>
+        <p:spPr>
+          <a:xfrm>
+            <a:off x="5854430" y="1880749"/>
+            <a:ext cx="4233153" cy="4351338"/>
+          </a:xfrm>
+          <a:prstGeom prst="rect">
+            <a:avLst/>
+          </a:prstGeom>
+        </p:spPr>
+        <p:txBody>
+          <a:bodyPr vert="horz" lIns="91440" tIns="45720" rIns="91440" bIns="45720" rtlCol="0">
+            <a:normAutofit/>
+          </a:bodyPr>
+          <a:lstStyle>
+            <a:lvl1pPr marL="228600" indent="-228600" algn="l" defTabSz="914400" rtl="0" eaLnBrk="1" latinLnBrk="0" hangingPunct="1">
+              <a:lnSpc>
+                <a:spcPct val="90000"/>
+              </a:lnSpc>
+              <a:spcBef>
+                <a:spcPts val="1000"/>
+              </a:spcBef>
+              <a:buFont typeface="Arial" panose="020B0604020202020204" pitchFamily="34" charset="0"/>
+              <a:buChar char="•"/>
+              <a:defRPr sz="2800" kern="1200">
+                <a:solidFill>
+                  <a:schemeClr val="tx1"/>
+                </a:solidFill>
+                <a:latin typeface="+mn-lt"/>
+                <a:ea typeface="+mn-ea"/>
+                <a:cs typeface="+mn-cs"/>
+              </a:defRPr>
+            </a:lvl1pPr>
+            <a:lvl2pPr marL="685800" indent="-228600" algn="l" defTabSz="914400" rtl="0" eaLnBrk="1" latinLnBrk="0" hangingPunct="1">
+              <a:lnSpc>
+                <a:spcPct val="90000"/>
+              </a:lnSpc>
+              <a:spcBef>
+                <a:spcPts val="500"/>
+              </a:spcBef>
+              <a:buFont typeface="Arial" panose="020B0604020202020204" pitchFamily="34" charset="0"/>
+              <a:buChar char="•"/>
+              <a:defRPr sz="2400" kern="1200">
+                <a:solidFill>
+                  <a:schemeClr val="tx1"/>
+                </a:solidFill>
+                <a:latin typeface="+mn-lt"/>
+                <a:ea typeface="+mn-ea"/>
+                <a:cs typeface="+mn-cs"/>
+              </a:defRPr>
+            </a:lvl2pPr>
+            <a:lvl3pPr marL="1143000" indent="-228600" algn="l" defTabSz="914400" rtl="0" eaLnBrk="1" latinLnBrk="0" hangingPunct="1">
+              <a:lnSpc>
+                <a:spcPct val="90000"/>
+              </a:lnSpc>
+              <a:spcBef>
+                <a:spcPts val="500"/>
+              </a:spcBef>
+              <a:buFont typeface="Arial" panose="020B0604020202020204" pitchFamily="34" charset="0"/>
+              <a:buChar char="•"/>
+              <a:defRPr sz="2000" kern="1200">
+                <a:solidFill>
+                  <a:schemeClr val="tx1"/>
+                </a:solidFill>
+                <a:latin typeface="+mn-lt"/>
+                <a:ea typeface="+mn-ea"/>
+                <a:cs typeface="+mn-cs"/>
+              </a:defRPr>
+            </a:lvl3pPr>
+            <a:lvl4pPr marL="1600200" indent="-228600" algn="l" defTabSz="914400" rtl="0" eaLnBrk="1" latinLnBrk="0" hangingPunct="1">
+              <a:lnSpc>
+                <a:spcPct val="90000"/>
+              </a:lnSpc>
+              <a:spcBef>
+                <a:spcPts val="500"/>
+              </a:spcBef>
+              <a:buFont typeface="Arial" panose="020B0604020202020204" pitchFamily="34" charset="0"/>
+              <a:buChar char="•"/>
+              <a:defRPr sz="1800" kern="1200">
+                <a:solidFill>
+                  <a:schemeClr val="tx1"/>
+                </a:solidFill>
+                <a:latin typeface="+mn-lt"/>
+                <a:ea typeface="+mn-ea"/>
+                <a:cs typeface="+mn-cs"/>
+              </a:defRPr>
+            </a:lvl4pPr>
+            <a:lvl5pPr marL="2057400" indent="-228600" algn="l" defTabSz="914400" rtl="0" eaLnBrk="1" latinLnBrk="0" hangingPunct="1">
+              <a:lnSpc>
+                <a:spcPct val="90000"/>
+              </a:lnSpc>
+              <a:spcBef>
+                <a:spcPts val="500"/>
+              </a:spcBef>
+              <a:buFont typeface="Arial" panose="020B0604020202020204" pitchFamily="34" charset="0"/>
+              <a:buChar char="•"/>
+              <a:defRPr sz="1800" kern="1200">
+                <a:solidFill>
+                  <a:schemeClr val="tx1"/>
+                </a:solidFill>
+                <a:latin typeface="+mn-lt"/>
+                <a:ea typeface="+mn-ea"/>
+                <a:cs typeface="+mn-cs"/>
+              </a:defRPr>
+            </a:lvl5pPr>
+            <a:lvl6pPr marL="2514600" indent="-228600" algn="l" defTabSz="914400" rtl="0" eaLnBrk="1" latinLnBrk="0" hangingPunct="1">
+              <a:lnSpc>
+                <a:spcPct val="90000"/>
+              </a:lnSpc>
+              <a:spcBef>
+                <a:spcPts val="500"/>
+              </a:spcBef>
+              <a:buFont typeface="Arial" panose="020B0604020202020204" pitchFamily="34" charset="0"/>
+              <a:buChar char="•"/>
+              <a:defRPr sz="1800" kern="1200">
+                <a:solidFill>
+                  <a:schemeClr val="tx1"/>
+                </a:solidFill>
+                <a:latin typeface="+mn-lt"/>
+                <a:ea typeface="+mn-ea"/>
+                <a:cs typeface="+mn-cs"/>
+              </a:defRPr>
+            </a:lvl6pPr>
+            <a:lvl7pPr marL="2971800" indent="-228600" algn="l" defTabSz="914400" rtl="0" eaLnBrk="1" latinLnBrk="0" hangingPunct="1">
+              <a:lnSpc>
+                <a:spcPct val="90000"/>
+              </a:lnSpc>
+              <a:spcBef>
+                <a:spcPts val="500"/>
+              </a:spcBef>
+              <a:buFont typeface="Arial" panose="020B0604020202020204" pitchFamily="34" charset="0"/>
+              <a:buChar char="•"/>
+              <a:defRPr sz="1800" kern="1200">
+                <a:solidFill>
+                  <a:schemeClr val="tx1"/>
+                </a:solidFill>
+                <a:latin typeface="+mn-lt"/>
+                <a:ea typeface="+mn-ea"/>
+                <a:cs typeface="+mn-cs"/>
+              </a:defRPr>
+            </a:lvl7pPr>
+            <a:lvl8pPr marL="3429000" indent="-228600" algn="l" defTabSz="914400" rtl="0" eaLnBrk="1" latinLnBrk="0" hangingPunct="1">
+              <a:lnSpc>
+                <a:spcPct val="90000"/>
+              </a:lnSpc>
+              <a:spcBef>
+                <a:spcPts val="500"/>
+              </a:spcBef>
+              <a:buFont typeface="Arial" panose="020B0604020202020204" pitchFamily="34" charset="0"/>
+              <a:buChar char="•"/>
+              <a:defRPr sz="1800" kern="1200">
+                <a:solidFill>
+                  <a:schemeClr val="tx1"/>
+                </a:solidFill>
+                <a:latin typeface="+mn-lt"/>
+                <a:ea typeface="+mn-ea"/>
+                <a:cs typeface="+mn-cs"/>
+              </a:defRPr>
+            </a:lvl8pPr>
+            <a:lvl9pPr marL="3886200" indent="-228600" algn="l" defTabSz="914400" rtl="0" eaLnBrk="1" latinLnBrk="0" hangingPunct="1">
+              <a:lnSpc>
+                <a:spcPct val="90000"/>
+              </a:lnSpc>
+              <a:spcBef>
+                <a:spcPts val="500"/>
+              </a:spcBef>
+              <a:buFont typeface="Arial" panose="020B0604020202020204" pitchFamily="34" charset="0"/>
+              <a:buChar char="•"/>
+              <a:defRPr sz="1800" kern="1200">
+                <a:solidFill>
+                  <a:schemeClr val="tx1"/>
+                </a:solidFill>
+                <a:latin typeface="+mn-lt"/>
+                <a:ea typeface="+mn-ea"/>
+                <a:cs typeface="+mn-cs"/>
+              </a:defRPr>
+            </a:lvl9pPr>
+          </a:lstStyle>
+          <a:p>
+            <a:pPr marL="0" indent="0">
+              <a:buFont typeface="Arial" panose="020B0604020202020204" pitchFamily="34" charset="0"/>
+              <a:buNone/>
+            </a:pPr>
+            <a:r>
+              <a:rPr lang="en-US" b="1" dirty="0"/>
+              <a:t>Why SDL2?</a:t>
+            </a:r>
+          </a:p>
+          <a:p>
+            <a:pPr>
+              <a:buFontTx/>
+              <a:buChar char="-"/>
+            </a:pPr>
+            <a:r>
+              <a:rPr lang="en-US" dirty="0"/>
+              <a:t>SDL can read multiple devices at the same time and can distinguish between them</a:t>
+            </a:r>
+          </a:p>
+          <a:p>
+            <a:pPr>
+              <a:buFontTx/>
+              <a:buChar char="-"/>
+            </a:pPr>
+            <a:r>
+              <a:rPr lang="en-US" dirty="0"/>
+              <a:t>SDL can be used across a variety of platforms without the hassle of using platform specific </a:t>
+            </a:r>
+            <a:r>
+              <a:rPr lang="en-US" dirty="0" err="1"/>
+              <a:t>apis</a:t>
+            </a:r>
             <a:endParaRPr lang="en-US" dirty="0"/>
+          </a:p>
+          <a:p>
+            <a:pPr>
+              <a:buFontTx/>
+              <a:buChar char="-"/>
+            </a:pPr>
+            <a:endParaRPr lang="en-GB" dirty="0"/>
           </a:p>
         </p:txBody>
       </p:sp>
     </p:spTree>
     <p:extLst>
       <p:ext uri="{BB962C8B-B14F-4D97-AF65-F5344CB8AC3E}">
-        <p14:creationId xmlns:p14="http://schemas.microsoft.com/office/powerpoint/2010/main" val="268863310"/>
+        <p14:creationId xmlns:p14="http://schemas.microsoft.com/office/powerpoint/2010/main" val="1667238636"/>
+      </p:ext>
+    </p:extLst>
+  </p:cSld>
+  <p:clrMapOvr>
+    <a:masterClrMapping/>
+  </p:clrMapOvr>
+</p:sld>
+</file>
+
+<file path=ppt/slides/slide9.xml><?xml version="1.0" encoding="utf-8"?>
+<p:sld xmlns:a="http://schemas.openxmlformats.org/drawingml/2006/main" xmlns:r="http://schemas.openxmlformats.org/officeDocument/2006/relationships" xmlns:p="http://schemas.openxmlformats.org/presentationml/2006/main">
+  <p:cSld>
+    <p:spTree>
+      <p:nvGrpSpPr>
+        <p:cNvPr id="1" name=""/>
+        <p:cNvGrpSpPr/>
+        <p:nvPr/>
+      </p:nvGrpSpPr>
+      <p:grpSpPr>
+        <a:xfrm>
+          <a:off x="0" y="0"/>
+          <a:ext cx="0" cy="0"/>
+          <a:chOff x="0" y="0"/>
+          <a:chExt cx="0" cy="0"/>
+        </a:xfrm>
+      </p:grpSpPr>
+      <p:sp>
+        <p:nvSpPr>
+          <p:cNvPr id="2" name="Title 1">
+            <a:extLst>
+              <a:ext uri="{FF2B5EF4-FFF2-40B4-BE49-F238E27FC236}">
+                <a16:creationId xmlns:a16="http://schemas.microsoft.com/office/drawing/2014/main" id="{CFB169EE-702B-AA41-A682-8DC7EDA2548E}"/>
+              </a:ext>
+            </a:extLst>
+          </p:cNvPr>
+          <p:cNvSpPr>
+            <a:spLocks noGrp="1"/>
+          </p:cNvSpPr>
+          <p:nvPr>
+            <p:ph type="title"/>
+          </p:nvPr>
+        </p:nvSpPr>
+        <p:spPr>
+          <a:xfrm>
+            <a:off x="838200" y="0"/>
+            <a:ext cx="10515600" cy="1325563"/>
+          </a:xfrm>
+        </p:spPr>
+        <p:txBody>
+          <a:bodyPr/>
+          <a:lstStyle/>
+          <a:p>
+            <a:r>
+              <a:rPr lang="en-US" dirty="0"/>
+              <a:t>How I use SDL2 to read input for my project</a:t>
+            </a:r>
+            <a:endParaRPr lang="en-GB" dirty="0"/>
+          </a:p>
+        </p:txBody>
+      </p:sp>
+      <p:sp>
+        <p:nvSpPr>
+          <p:cNvPr id="3" name="Content Placeholder 2">
+            <a:extLst>
+              <a:ext uri="{FF2B5EF4-FFF2-40B4-BE49-F238E27FC236}">
+                <a16:creationId xmlns:a16="http://schemas.microsoft.com/office/drawing/2014/main" id="{2B1A5B1D-E2DC-AE19-61B0-253CD63E821A}"/>
+              </a:ext>
+            </a:extLst>
+          </p:cNvPr>
+          <p:cNvSpPr>
+            <a:spLocks noGrp="1"/>
+          </p:cNvSpPr>
+          <p:nvPr>
+            <p:ph idx="1"/>
+          </p:nvPr>
+        </p:nvSpPr>
+        <p:spPr>
+          <a:xfrm>
+            <a:off x="838200" y="1092760"/>
+            <a:ext cx="4025630" cy="748962"/>
+          </a:xfrm>
+        </p:spPr>
+        <p:txBody>
+          <a:bodyPr>
+            <a:normAutofit fontScale="92500" lnSpcReduction="10000"/>
+          </a:bodyPr>
+          <a:lstStyle/>
+          <a:p>
+            <a:r>
+              <a:rPr lang="en-US" b="1" dirty="0"/>
+              <a:t>How a keypress event is processed</a:t>
+            </a:r>
+            <a:endParaRPr lang="en-GB" b="1" dirty="0"/>
+          </a:p>
+        </p:txBody>
+      </p:sp>
+      <p:pic>
+        <p:nvPicPr>
+          <p:cNvPr id="5" name="Picture 4">
+            <a:extLst>
+              <a:ext uri="{FF2B5EF4-FFF2-40B4-BE49-F238E27FC236}">
+                <a16:creationId xmlns:a16="http://schemas.microsoft.com/office/drawing/2014/main" id="{4FB62D5B-5997-6499-A455-A166543C6E37}"/>
+              </a:ext>
+            </a:extLst>
+          </p:cNvPr>
+          <p:cNvPicPr>
+            <a:picLocks noChangeAspect="1"/>
+          </p:cNvPicPr>
+          <p:nvPr/>
+        </p:nvPicPr>
+        <p:blipFill>
+          <a:blip r:embed="rId2"/>
+          <a:stretch>
+            <a:fillRect/>
+          </a:stretch>
+        </p:blipFill>
+        <p:spPr>
+          <a:xfrm>
+            <a:off x="705953" y="1968414"/>
+            <a:ext cx="4290124" cy="4624245"/>
+          </a:xfrm>
+          <a:prstGeom prst="rect">
+            <a:avLst/>
+          </a:prstGeom>
+        </p:spPr>
+      </p:pic>
+      <p:sp>
+        <p:nvSpPr>
+          <p:cNvPr id="6" name="TextBox 5">
+            <a:extLst>
+              <a:ext uri="{FF2B5EF4-FFF2-40B4-BE49-F238E27FC236}">
+                <a16:creationId xmlns:a16="http://schemas.microsoft.com/office/drawing/2014/main" id="{50D2E389-8E51-67F9-BC5F-A71F5E1C09E4}"/>
+              </a:ext>
+            </a:extLst>
+          </p:cNvPr>
+          <p:cNvSpPr txBox="1"/>
+          <p:nvPr/>
+        </p:nvSpPr>
+        <p:spPr>
+          <a:xfrm>
+            <a:off x="5654489" y="1156447"/>
+            <a:ext cx="6158752" cy="5262979"/>
+          </a:xfrm>
+          <a:prstGeom prst="rect">
+            <a:avLst/>
+          </a:prstGeom>
+          <a:noFill/>
+        </p:spPr>
+        <p:txBody>
+          <a:bodyPr wrap="square" rtlCol="0">
+            <a:spAutoFit/>
+          </a:bodyPr>
+          <a:lstStyle/>
+          <a:p>
+            <a:r>
+              <a:rPr lang="en-US" sz="2800" b="1" dirty="0"/>
+              <a:t>Key points</a:t>
+            </a:r>
+            <a:br>
+              <a:rPr lang="en-US" sz="2800" b="1" dirty="0"/>
+            </a:br>
+            <a:r>
+              <a:rPr lang="en-US" sz="2800" dirty="0"/>
+              <a:t>- input events are discovered and sent in the main program thread</a:t>
+            </a:r>
+          </a:p>
+          <a:p>
+            <a:endParaRPr lang="en-US" sz="2800" dirty="0"/>
+          </a:p>
+          <a:p>
+            <a:r>
+              <a:rPr lang="en-US" sz="2800" dirty="0"/>
+              <a:t>- Each device has a unique input translator class which is stored per game instance</a:t>
+            </a:r>
+          </a:p>
+          <a:p>
+            <a:endParaRPr lang="en-US" sz="2800" dirty="0"/>
+          </a:p>
+          <a:p>
+            <a:r>
+              <a:rPr lang="en-US" sz="2800" dirty="0"/>
+              <a:t>- The input translator class stores the current state of the device, including which keys are pressed and where the cursor is</a:t>
+            </a:r>
+            <a:endParaRPr lang="en-GB" sz="2800" dirty="0"/>
+          </a:p>
+        </p:txBody>
+      </p:sp>
+    </p:spTree>
+    <p:extLst>
+      <p:ext uri="{BB962C8B-B14F-4D97-AF65-F5344CB8AC3E}">
+        <p14:creationId xmlns:p14="http://schemas.microsoft.com/office/powerpoint/2010/main" val="1763007847"/>
       </p:ext>
     </p:extLst>
   </p:cSld>

</xml_diff>